<commit_message>
Update PowerPoint Les 1: Wat is politiek (brugklas)
</commit_message>
<xml_diff>
--- a/lessen/politiek/materiaal/Les1_Wat_Is_Politiek.pptx
+++ b/lessen/politiek/materiaal/Les1_Wat_Is_Politiek.pptx
@@ -292,7 +292,9 @@
         <p:txBody>
           <a:bodyPr/>
           <a:lstStyle/>
-          <a:p/>
+          <a:p>
+            <a:endParaRPr/>
+          </a:p>
         </p:txBody>
       </p:sp>
       <p:sp>
@@ -374,7 +376,9 @@
         <p:txBody>
           <a:bodyPr/>
           <a:lstStyle/>
-          <a:p/>
+          <a:p>
+            <a:endParaRPr/>
+          </a:p>
         </p:txBody>
       </p:sp>
       <p:sp>
@@ -456,7 +460,9 @@
         <p:txBody>
           <a:bodyPr/>
           <a:lstStyle/>
-          <a:p/>
+          <a:p>
+            <a:endParaRPr/>
+          </a:p>
         </p:txBody>
       </p:sp>
       <p:sp>
@@ -538,7 +544,9 @@
         <p:txBody>
           <a:bodyPr/>
           <a:lstStyle/>
-          <a:p/>
+          <a:p>
+            <a:endParaRPr/>
+          </a:p>
         </p:txBody>
       </p:sp>
       <p:sp>
@@ -620,7 +628,9 @@
         <p:txBody>
           <a:bodyPr/>
           <a:lstStyle/>
-          <a:p/>
+          <a:p>
+            <a:endParaRPr/>
+          </a:p>
         </p:txBody>
       </p:sp>
       <p:sp>
@@ -702,7 +712,9 @@
         <p:txBody>
           <a:bodyPr/>
           <a:lstStyle/>
-          <a:p/>
+          <a:p>
+            <a:endParaRPr/>
+          </a:p>
         </p:txBody>
       </p:sp>
       <p:sp>
@@ -784,7 +796,9 @@
         <p:txBody>
           <a:bodyPr/>
           <a:lstStyle/>
-          <a:p/>
+          <a:p>
+            <a:endParaRPr/>
+          </a:p>
         </p:txBody>
       </p:sp>
       <p:sp>
@@ -866,7 +880,9 @@
         <p:txBody>
           <a:bodyPr/>
           <a:lstStyle/>
-          <a:p/>
+          <a:p>
+            <a:endParaRPr/>
+          </a:p>
         </p:txBody>
       </p:sp>
       <p:sp>
@@ -948,7 +964,9 @@
         <p:txBody>
           <a:bodyPr/>
           <a:lstStyle/>
-          <a:p/>
+          <a:p>
+            <a:endParaRPr/>
+          </a:p>
         </p:txBody>
       </p:sp>
       <p:sp>
@@ -1030,7 +1048,9 @@
         <p:txBody>
           <a:bodyPr/>
           <a:lstStyle/>
-          <a:p/>
+          <a:p>
+            <a:endParaRPr/>
+          </a:p>
         </p:txBody>
       </p:sp>
       <p:sp>
@@ -1112,7 +1132,9 @@
         <p:txBody>
           <a:bodyPr/>
           <a:lstStyle/>
-          <a:p/>
+          <a:p>
+            <a:endParaRPr/>
+          </a:p>
         </p:txBody>
       </p:sp>
       <p:sp>
@@ -1194,7 +1216,9 @@
         <p:txBody>
           <a:bodyPr/>
           <a:lstStyle/>
-          <a:p/>
+          <a:p>
+            <a:endParaRPr/>
+          </a:p>
         </p:txBody>
       </p:sp>
       <p:sp>
@@ -1276,7 +1300,9 @@
         <p:txBody>
           <a:bodyPr/>
           <a:lstStyle/>
-          <a:p/>
+          <a:p>
+            <a:endParaRPr/>
+          </a:p>
         </p:txBody>
       </p:sp>
       <p:sp>
@@ -4557,7 +4583,7 @@
               <a:buNone/>
             </a:pPr>
             <a:r>
-              <a:rPr lang="en-US" sz="1800" b="1" dirty="0">
+              <a:rPr lang="en-US" b="1" dirty="0">
                 <a:solidFill>
                   <a:srgbClr val="1E293B"/>
                 </a:solidFill>
@@ -4565,7 +4591,29 @@
                 <a:ea typeface="Calibri" pitchFamily="34" charset="-122"/>
                 <a:cs typeface="Calibri" pitchFamily="34" charset="-120"/>
               </a:rPr>
-              <a:t>3 EENS + 3 ONEENS</a:t>
+              <a:t>6 fiches (3 rood &amp; 3 </a:t>
+            </a:r>
+            <a:r>
+              <a:rPr lang="en-US" b="1" dirty="0" err="1">
+                <a:solidFill>
+                  <a:srgbClr val="1E293B"/>
+                </a:solidFill>
+                <a:latin typeface="Calibri" pitchFamily="34" charset="0"/>
+                <a:ea typeface="Calibri" pitchFamily="34" charset="-122"/>
+                <a:cs typeface="Calibri" pitchFamily="34" charset="-120"/>
+              </a:rPr>
+              <a:t>groen</a:t>
+            </a:r>
+            <a:r>
+              <a:rPr lang="en-US" b="1" dirty="0">
+                <a:solidFill>
+                  <a:srgbClr val="1E293B"/>
+                </a:solidFill>
+                <a:latin typeface="Calibri" pitchFamily="34" charset="0"/>
+                <a:ea typeface="Calibri" pitchFamily="34" charset="-122"/>
+                <a:cs typeface="Calibri" pitchFamily="34" charset="-120"/>
+              </a:rPr>
+              <a:t>)</a:t>
             </a:r>
             <a:endParaRPr lang="en-US" sz="1800" dirty="0"/>
           </a:p>
@@ -4604,7 +4652,337 @@
                 <a:ea typeface="Calibri" pitchFamily="34" charset="-122"/>
                 <a:cs typeface="Calibri" pitchFamily="34" charset="-120"/>
               </a:rPr>
-              <a:t>Jouw hand. Je hebt minder kaarten dan stemmen — dus je moet kiezen.</a:t>
+              <a:t>Jouw hand. Met </a:t>
+            </a:r>
+            <a:r>
+              <a:rPr lang="en-US" sz="1400" dirty="0" err="1">
+                <a:solidFill>
+                  <a:srgbClr val="475569"/>
+                </a:solidFill>
+                <a:latin typeface="Calibri" pitchFamily="34" charset="0"/>
+                <a:ea typeface="Calibri" pitchFamily="34" charset="-122"/>
+                <a:cs typeface="Calibri" pitchFamily="34" charset="-120"/>
+              </a:rPr>
+              <a:t>groen</a:t>
+            </a:r>
+            <a:r>
+              <a:rPr lang="en-US" sz="1400" dirty="0">
+                <a:solidFill>
+                  <a:srgbClr val="475569"/>
+                </a:solidFill>
+                <a:latin typeface="Calibri" pitchFamily="34" charset="0"/>
+                <a:ea typeface="Calibri" pitchFamily="34" charset="-122"/>
+                <a:cs typeface="Calibri" pitchFamily="34" charset="-120"/>
+              </a:rPr>
+              <a:t> stem je </a:t>
+            </a:r>
+            <a:r>
+              <a:rPr lang="en-US" sz="1400" dirty="0" err="1">
+                <a:solidFill>
+                  <a:srgbClr val="475569"/>
+                </a:solidFill>
+                <a:latin typeface="Calibri" pitchFamily="34" charset="0"/>
+                <a:ea typeface="Calibri" pitchFamily="34" charset="-122"/>
+                <a:cs typeface="Calibri" pitchFamily="34" charset="-120"/>
+              </a:rPr>
+              <a:t>voor</a:t>
+            </a:r>
+            <a:r>
+              <a:rPr lang="en-US" sz="1400" dirty="0">
+                <a:solidFill>
+                  <a:srgbClr val="475569"/>
+                </a:solidFill>
+                <a:latin typeface="Calibri" pitchFamily="34" charset="0"/>
+                <a:ea typeface="Calibri" pitchFamily="34" charset="-122"/>
+                <a:cs typeface="Calibri" pitchFamily="34" charset="-120"/>
+              </a:rPr>
+              <a:t>, met rood </a:t>
+            </a:r>
+            <a:r>
+              <a:rPr lang="en-US" sz="1400" dirty="0" err="1">
+                <a:solidFill>
+                  <a:srgbClr val="475569"/>
+                </a:solidFill>
+                <a:latin typeface="Calibri" pitchFamily="34" charset="0"/>
+                <a:ea typeface="Calibri" pitchFamily="34" charset="-122"/>
+                <a:cs typeface="Calibri" pitchFamily="34" charset="-120"/>
+              </a:rPr>
+              <a:t>tegen</a:t>
+            </a:r>
+            <a:r>
+              <a:rPr lang="en-US" sz="1400" dirty="0">
+                <a:solidFill>
+                  <a:srgbClr val="475569"/>
+                </a:solidFill>
+                <a:latin typeface="Calibri" pitchFamily="34" charset="0"/>
+                <a:ea typeface="Calibri" pitchFamily="34" charset="-122"/>
+                <a:cs typeface="Calibri" pitchFamily="34" charset="-120"/>
+              </a:rPr>
+              <a:t>. Je </a:t>
+            </a:r>
+            <a:r>
+              <a:rPr lang="en-US" sz="1400" dirty="0" err="1">
+                <a:solidFill>
+                  <a:srgbClr val="475569"/>
+                </a:solidFill>
+                <a:latin typeface="Calibri" pitchFamily="34" charset="0"/>
+                <a:ea typeface="Calibri" pitchFamily="34" charset="-122"/>
+                <a:cs typeface="Calibri" pitchFamily="34" charset="-120"/>
+              </a:rPr>
+              <a:t>hebt</a:t>
+            </a:r>
+            <a:r>
+              <a:rPr lang="en-US" sz="1400" dirty="0">
+                <a:solidFill>
+                  <a:srgbClr val="475569"/>
+                </a:solidFill>
+                <a:latin typeface="Calibri" pitchFamily="34" charset="0"/>
+                <a:ea typeface="Calibri" pitchFamily="34" charset="-122"/>
+                <a:cs typeface="Calibri" pitchFamily="34" charset="-120"/>
+              </a:rPr>
+              <a:t> </a:t>
+            </a:r>
+            <a:r>
+              <a:rPr lang="en-US" sz="1400" dirty="0" err="1">
+                <a:solidFill>
+                  <a:srgbClr val="475569"/>
+                </a:solidFill>
+                <a:latin typeface="Calibri" pitchFamily="34" charset="0"/>
+                <a:ea typeface="Calibri" pitchFamily="34" charset="-122"/>
+                <a:cs typeface="Calibri" pitchFamily="34" charset="-120"/>
+              </a:rPr>
+              <a:t>dus</a:t>
+            </a:r>
+            <a:r>
+              <a:rPr lang="en-US" sz="1400" dirty="0">
+                <a:solidFill>
+                  <a:srgbClr val="475569"/>
+                </a:solidFill>
+                <a:latin typeface="Calibri" pitchFamily="34" charset="0"/>
+                <a:ea typeface="Calibri" pitchFamily="34" charset="-122"/>
+                <a:cs typeface="Calibri" pitchFamily="34" charset="-120"/>
+              </a:rPr>
+              <a:t> maar 3 </a:t>
+            </a:r>
+            <a:r>
+              <a:rPr lang="en-US" sz="1400" dirty="0" err="1">
+                <a:solidFill>
+                  <a:srgbClr val="475569"/>
+                </a:solidFill>
+                <a:latin typeface="Calibri" pitchFamily="34" charset="0"/>
+                <a:ea typeface="Calibri" pitchFamily="34" charset="-122"/>
+                <a:cs typeface="Calibri" pitchFamily="34" charset="-120"/>
+              </a:rPr>
+              <a:t>voor</a:t>
+            </a:r>
+            <a:r>
+              <a:rPr lang="en-US" sz="1400" dirty="0">
+                <a:solidFill>
+                  <a:srgbClr val="475569"/>
+                </a:solidFill>
+                <a:latin typeface="Calibri" pitchFamily="34" charset="0"/>
+                <a:ea typeface="Calibri" pitchFamily="34" charset="-122"/>
+                <a:cs typeface="Calibri" pitchFamily="34" charset="-120"/>
+              </a:rPr>
+              <a:t> </a:t>
+            </a:r>
+            <a:r>
+              <a:rPr lang="en-US" sz="1400" dirty="0" err="1">
+                <a:solidFill>
+                  <a:srgbClr val="475569"/>
+                </a:solidFill>
+                <a:latin typeface="Calibri" pitchFamily="34" charset="0"/>
+                <a:ea typeface="Calibri" pitchFamily="34" charset="-122"/>
+                <a:cs typeface="Calibri" pitchFamily="34" charset="-120"/>
+              </a:rPr>
+              <a:t>en</a:t>
+            </a:r>
+            <a:r>
+              <a:rPr lang="en-US" sz="1400" dirty="0">
+                <a:solidFill>
+                  <a:srgbClr val="475569"/>
+                </a:solidFill>
+                <a:latin typeface="Calibri" pitchFamily="34" charset="0"/>
+                <a:ea typeface="Calibri" pitchFamily="34" charset="-122"/>
+                <a:cs typeface="Calibri" pitchFamily="34" charset="-120"/>
+              </a:rPr>
+              <a:t> 3 </a:t>
+            </a:r>
+            <a:r>
+              <a:rPr lang="en-US" sz="1400" dirty="0" err="1">
+                <a:solidFill>
+                  <a:srgbClr val="475569"/>
+                </a:solidFill>
+                <a:latin typeface="Calibri" pitchFamily="34" charset="0"/>
+                <a:ea typeface="Calibri" pitchFamily="34" charset="-122"/>
+                <a:cs typeface="Calibri" pitchFamily="34" charset="-120"/>
+              </a:rPr>
+              <a:t>tegen</a:t>
+            </a:r>
+            <a:r>
+              <a:rPr lang="en-US" sz="1400" dirty="0">
+                <a:solidFill>
+                  <a:srgbClr val="475569"/>
+                </a:solidFill>
+                <a:latin typeface="Calibri" pitchFamily="34" charset="0"/>
+                <a:ea typeface="Calibri" pitchFamily="34" charset="-122"/>
+                <a:cs typeface="Calibri" pitchFamily="34" charset="-120"/>
+              </a:rPr>
+              <a:t> </a:t>
+            </a:r>
+            <a:r>
+              <a:rPr lang="en-US" sz="1400" dirty="0" err="1">
+                <a:solidFill>
+                  <a:srgbClr val="475569"/>
+                </a:solidFill>
+                <a:latin typeface="Calibri" pitchFamily="34" charset="0"/>
+                <a:ea typeface="Calibri" pitchFamily="34" charset="-122"/>
+                <a:cs typeface="Calibri" pitchFamily="34" charset="-120"/>
+              </a:rPr>
+              <a:t>stemmen</a:t>
+            </a:r>
+            <a:r>
+              <a:rPr lang="en-US" sz="1400" dirty="0">
+                <a:solidFill>
+                  <a:srgbClr val="475569"/>
+                </a:solidFill>
+                <a:latin typeface="Calibri" pitchFamily="34" charset="0"/>
+                <a:ea typeface="Calibri" pitchFamily="34" charset="-122"/>
+                <a:cs typeface="Calibri" pitchFamily="34" charset="-120"/>
+              </a:rPr>
+              <a:t>, </a:t>
+            </a:r>
+            <a:r>
+              <a:rPr lang="en-US" sz="1400" dirty="0" err="1">
+                <a:solidFill>
+                  <a:srgbClr val="475569"/>
+                </a:solidFill>
+                <a:latin typeface="Calibri" pitchFamily="34" charset="0"/>
+                <a:ea typeface="Calibri" pitchFamily="34" charset="-122"/>
+                <a:cs typeface="Calibri" pitchFamily="34" charset="-120"/>
+              </a:rPr>
+              <a:t>terwijl</a:t>
+            </a:r>
+            <a:r>
+              <a:rPr lang="en-US" sz="1400" dirty="0">
+                <a:solidFill>
+                  <a:srgbClr val="475569"/>
+                </a:solidFill>
+                <a:latin typeface="Calibri" pitchFamily="34" charset="0"/>
+                <a:ea typeface="Calibri" pitchFamily="34" charset="-122"/>
+                <a:cs typeface="Calibri" pitchFamily="34" charset="-120"/>
+              </a:rPr>
+              <a:t> er 6 </a:t>
+            </a:r>
+            <a:r>
+              <a:rPr lang="en-US" sz="1400" dirty="0" err="1">
+                <a:solidFill>
+                  <a:srgbClr val="475569"/>
+                </a:solidFill>
+                <a:latin typeface="Calibri" pitchFamily="34" charset="0"/>
+                <a:ea typeface="Calibri" pitchFamily="34" charset="-122"/>
+                <a:cs typeface="Calibri" pitchFamily="34" charset="-120"/>
+              </a:rPr>
+              <a:t>voorstellen</a:t>
+            </a:r>
+            <a:r>
+              <a:rPr lang="en-US" sz="1400" dirty="0">
+                <a:solidFill>
+                  <a:srgbClr val="475569"/>
+                </a:solidFill>
+                <a:latin typeface="Calibri" pitchFamily="34" charset="0"/>
+                <a:ea typeface="Calibri" pitchFamily="34" charset="-122"/>
+                <a:cs typeface="Calibri" pitchFamily="34" charset="-120"/>
+              </a:rPr>
+              <a:t> </a:t>
+            </a:r>
+            <a:r>
+              <a:rPr lang="en-US" sz="1400" dirty="0" err="1">
+                <a:solidFill>
+                  <a:srgbClr val="475569"/>
+                </a:solidFill>
+                <a:latin typeface="Calibri" pitchFamily="34" charset="0"/>
+                <a:ea typeface="Calibri" pitchFamily="34" charset="-122"/>
+                <a:cs typeface="Calibri" pitchFamily="34" charset="-120"/>
+              </a:rPr>
+              <a:t>zijn</a:t>
+            </a:r>
+            <a:r>
+              <a:rPr lang="en-US" sz="1400" dirty="0">
+                <a:solidFill>
+                  <a:srgbClr val="475569"/>
+                </a:solidFill>
+                <a:latin typeface="Calibri" pitchFamily="34" charset="0"/>
+                <a:ea typeface="Calibri" pitchFamily="34" charset="-122"/>
+                <a:cs typeface="Calibri" pitchFamily="34" charset="-120"/>
+              </a:rPr>
+              <a:t>. Je </a:t>
+            </a:r>
+            <a:r>
+              <a:rPr lang="en-US" sz="1400" dirty="0" err="1">
+                <a:solidFill>
+                  <a:srgbClr val="475569"/>
+                </a:solidFill>
+                <a:latin typeface="Calibri" pitchFamily="34" charset="0"/>
+                <a:ea typeface="Calibri" pitchFamily="34" charset="-122"/>
+                <a:cs typeface="Calibri" pitchFamily="34" charset="-120"/>
+              </a:rPr>
+              <a:t>moet</a:t>
+            </a:r>
+            <a:r>
+              <a:rPr lang="en-US" sz="1400" dirty="0">
+                <a:solidFill>
+                  <a:srgbClr val="475569"/>
+                </a:solidFill>
+                <a:latin typeface="Calibri" pitchFamily="34" charset="0"/>
+                <a:ea typeface="Calibri" pitchFamily="34" charset="-122"/>
+                <a:cs typeface="Calibri" pitchFamily="34" charset="-120"/>
+              </a:rPr>
+              <a:t> </a:t>
+            </a:r>
+            <a:r>
+              <a:rPr lang="en-US" sz="1400" dirty="0" err="1">
+                <a:solidFill>
+                  <a:srgbClr val="475569"/>
+                </a:solidFill>
+                <a:latin typeface="Calibri" pitchFamily="34" charset="0"/>
+                <a:ea typeface="Calibri" pitchFamily="34" charset="-122"/>
+                <a:cs typeface="Calibri" pitchFamily="34" charset="-120"/>
+              </a:rPr>
+              <a:t>dus</a:t>
+            </a:r>
+            <a:r>
+              <a:rPr lang="en-US" sz="1400" dirty="0">
+                <a:solidFill>
+                  <a:srgbClr val="475569"/>
+                </a:solidFill>
+                <a:latin typeface="Calibri" pitchFamily="34" charset="0"/>
+                <a:ea typeface="Calibri" pitchFamily="34" charset="-122"/>
+                <a:cs typeface="Calibri" pitchFamily="34" charset="-120"/>
+              </a:rPr>
+              <a:t> </a:t>
+            </a:r>
+            <a:r>
+              <a:rPr lang="en-US" sz="1400" dirty="0" err="1">
+                <a:solidFill>
+                  <a:srgbClr val="475569"/>
+                </a:solidFill>
+                <a:latin typeface="Calibri" pitchFamily="34" charset="0"/>
+                <a:ea typeface="Calibri" pitchFamily="34" charset="-122"/>
+                <a:cs typeface="Calibri" pitchFamily="34" charset="-120"/>
+              </a:rPr>
+              <a:t>kiezen</a:t>
+            </a:r>
+            <a:r>
+              <a:rPr lang="en-US" sz="1400" dirty="0">
+                <a:solidFill>
+                  <a:srgbClr val="475569"/>
+                </a:solidFill>
+                <a:latin typeface="Calibri" pitchFamily="34" charset="0"/>
+                <a:ea typeface="Calibri" pitchFamily="34" charset="-122"/>
+                <a:cs typeface="Calibri" pitchFamily="34" charset="-120"/>
+              </a:rPr>
+              <a:t>!</a:t>
             </a:r>
             <a:endParaRPr lang="en-US" sz="1400" dirty="0"/>
           </a:p>

</xml_diff>